<commit_message>
meeting notes in ppt
</commit_message>
<xml_diff>
--- a/notes/HAML.WorkingGroup.2024.11.18.pptx
+++ b/notes/HAML.WorkingGroup.2024.11.18.pptx
@@ -5,19 +5,21 @@
     <p:sldMasterId id="2147483659" r:id="rId1"/>
   </p:sldMasterIdLst>
   <p:notesMasterIdLst>
-    <p:notesMasterId r:id="rId12"/>
+    <p:notesMasterId r:id="rId14"/>
   </p:notesMasterIdLst>
   <p:sldIdLst>
     <p:sldId id="256" r:id="rId2"/>
-    <p:sldId id="263" r:id="rId3"/>
-    <p:sldId id="257" r:id="rId4"/>
-    <p:sldId id="265" r:id="rId5"/>
-    <p:sldId id="264" r:id="rId6"/>
-    <p:sldId id="258" r:id="rId7"/>
-    <p:sldId id="267" r:id="rId8"/>
-    <p:sldId id="260" r:id="rId9"/>
-    <p:sldId id="266" r:id="rId10"/>
-    <p:sldId id="261" r:id="rId11"/>
+    <p:sldId id="269" r:id="rId3"/>
+    <p:sldId id="263" r:id="rId4"/>
+    <p:sldId id="257" r:id="rId5"/>
+    <p:sldId id="265" r:id="rId6"/>
+    <p:sldId id="264" r:id="rId7"/>
+    <p:sldId id="258" r:id="rId8"/>
+    <p:sldId id="267" r:id="rId9"/>
+    <p:sldId id="260" r:id="rId10"/>
+    <p:sldId id="266" r:id="rId11"/>
+    <p:sldId id="261" r:id="rId12"/>
+    <p:sldId id="268" r:id="rId13"/>
   </p:sldIdLst>
   <p:sldSz cx="9144000" cy="5143500" type="screen16x9"/>
   <p:notesSz cx="6858000" cy="9144000"/>
@@ -802,7 +804,7 @@
               </a:spcAft>
               <a:buNone/>
             </a:pPr>
-            <a:endParaRPr/>
+            <a:endParaRPr dirty="0"/>
           </a:p>
         </p:txBody>
       </p:sp>
@@ -6099,6 +6101,348 @@
   <p:cSld>
     <p:spTree>
       <p:nvGrpSpPr>
+        <p:cNvPr id="1" name=""/>
+        <p:cNvGrpSpPr/>
+        <p:nvPr/>
+      </p:nvGrpSpPr>
+      <p:grpSpPr>
+        <a:xfrm>
+          <a:off x="0" y="0"/>
+          <a:ext cx="0" cy="0"/>
+          <a:chOff x="0" y="0"/>
+          <a:chExt cx="0" cy="0"/>
+        </a:xfrm>
+      </p:grpSpPr>
+      <p:sp>
+        <p:nvSpPr>
+          <p:cNvPr id="2" name="Title 1">
+            <a:extLst>
+              <a:ext uri="{FF2B5EF4-FFF2-40B4-BE49-F238E27FC236}">
+                <a16:creationId xmlns:a16="http://schemas.microsoft.com/office/drawing/2014/main" id="{0A8CF40D-5DEC-82FB-80E2-93FE6A785734}"/>
+              </a:ext>
+            </a:extLst>
+          </p:cNvPr>
+          <p:cNvSpPr>
+            <a:spLocks noGrp="1"/>
+          </p:cNvSpPr>
+          <p:nvPr>
+            <p:ph type="title"/>
+          </p:nvPr>
+        </p:nvSpPr>
+        <p:spPr/>
+        <p:txBody>
+          <a:bodyPr>
+            <a:normAutofit fontScale="90000"/>
+          </a:bodyPr>
+          <a:lstStyle/>
+          <a:p>
+            <a:r>
+              <a:rPr lang="en-NL" dirty="0"/>
+              <a:t>Tools &amp; Links</a:t>
+            </a:r>
+          </a:p>
+        </p:txBody>
+      </p:sp>
+      <p:sp>
+        <p:nvSpPr>
+          <p:cNvPr id="3" name="Text Placeholder 2">
+            <a:extLst>
+              <a:ext uri="{FF2B5EF4-FFF2-40B4-BE49-F238E27FC236}">
+                <a16:creationId xmlns:a16="http://schemas.microsoft.com/office/drawing/2014/main" id="{5F87125B-831A-433A-F4B2-3D1BBBB95F01}"/>
+              </a:ext>
+            </a:extLst>
+          </p:cNvPr>
+          <p:cNvSpPr>
+            <a:spLocks noGrp="1"/>
+          </p:cNvSpPr>
+          <p:nvPr>
+            <p:ph type="body" idx="1"/>
+          </p:nvPr>
+        </p:nvSpPr>
+        <p:spPr/>
+        <p:txBody>
+          <a:bodyPr>
+            <a:normAutofit lnSpcReduction="10000"/>
+          </a:bodyPr>
+          <a:lstStyle/>
+          <a:p>
+            <a:r>
+              <a:rPr lang="en-GB" dirty="0">
+                <a:hlinkClick r:id="rId2"/>
+              </a:rPr>
+              <a:t>https://github.com/bmatern/haml</a:t>
+            </a:r>
+            <a:endParaRPr lang="en-GB" dirty="0">
+              <a:effectLst/>
+              <a:latin typeface="Helvetica Neue" panose="02000503000000020004" pitchFamily="2" charset="0"/>
+              <a:hlinkClick r:id="rId3"/>
+            </a:endParaRPr>
+          </a:p>
+          <a:p>
+            <a:endParaRPr lang="en-GB" dirty="0">
+              <a:latin typeface="Helvetica Neue" panose="02000503000000020004" pitchFamily="2" charset="0"/>
+              <a:hlinkClick r:id="rId3"/>
+            </a:endParaRPr>
+          </a:p>
+          <a:p>
+            <a:r>
+              <a:rPr lang="en-GB" dirty="0">
+                <a:effectLst/>
+                <a:latin typeface="Helvetica Neue" panose="02000503000000020004" pitchFamily="2" charset="0"/>
+                <a:hlinkClick r:id="rId3"/>
+              </a:rPr>
+              <a:t>https://sourceforge.net/projects/xsdvi/</a:t>
+            </a:r>
+            <a:endParaRPr lang="en-GB" dirty="0">
+              <a:effectLst/>
+              <a:latin typeface="Helvetica Neue" panose="02000503000000020004" pitchFamily="2" charset="0"/>
+            </a:endParaRPr>
+          </a:p>
+          <a:p>
+            <a:pPr lvl="1"/>
+            <a:r>
+              <a:rPr lang="en-GB" dirty="0">
+                <a:effectLst/>
+                <a:latin typeface="Helvetica Neue" panose="02000503000000020004" pitchFamily="2" charset="0"/>
+              </a:rPr>
+              <a:t>Java-based </a:t>
+            </a:r>
+            <a:r>
+              <a:rPr lang="en-GB" dirty="0">
+                <a:latin typeface="Helvetica Neue" panose="02000503000000020004" pitchFamily="2" charset="0"/>
+              </a:rPr>
+              <a:t>schema diagram generator</a:t>
+            </a:r>
+          </a:p>
+          <a:p>
+            <a:pPr lvl="1"/>
+            <a:r>
+              <a:rPr lang="en-GB" sz="800" dirty="0">
+                <a:solidFill>
+                  <a:srgbClr val="000000"/>
+                </a:solidFill>
+                <a:effectLst/>
+                <a:latin typeface="Menlo" panose="020B0609030804020204" pitchFamily="49" charset="0"/>
+              </a:rPr>
+              <a:t>java -jar </a:t>
+            </a:r>
+            <a:r>
+              <a:rPr lang="en-GB" sz="800" dirty="0" err="1">
+                <a:solidFill>
+                  <a:srgbClr val="000000"/>
+                </a:solidFill>
+                <a:effectLst/>
+                <a:latin typeface="Menlo" panose="020B0609030804020204" pitchFamily="49" charset="0"/>
+              </a:rPr>
+              <a:t>dist</a:t>
+            </a:r>
+            <a:r>
+              <a:rPr lang="en-GB" sz="800" dirty="0">
+                <a:solidFill>
+                  <a:srgbClr val="000000"/>
+                </a:solidFill>
+                <a:effectLst/>
+                <a:latin typeface="Menlo" panose="020B0609030804020204" pitchFamily="49" charset="0"/>
+              </a:rPr>
+              <a:t>/lib/</a:t>
+            </a:r>
+            <a:r>
+              <a:rPr lang="en-GB" sz="800" dirty="0" err="1">
+                <a:solidFill>
+                  <a:srgbClr val="000000"/>
+                </a:solidFill>
+                <a:effectLst/>
+                <a:latin typeface="Menlo" panose="020B0609030804020204" pitchFamily="49" charset="0"/>
+              </a:rPr>
+              <a:t>xsdvi.jar</a:t>
+            </a:r>
+            <a:r>
+              <a:rPr lang="en-GB" sz="800" dirty="0">
+                <a:solidFill>
+                  <a:srgbClr val="000000"/>
+                </a:solidFill>
+                <a:effectLst/>
+                <a:latin typeface="Menlo" panose="020B0609030804020204" pitchFamily="49" charset="0"/>
+              </a:rPr>
+              <a:t> /Users/ben/</a:t>
+            </a:r>
+            <a:r>
+              <a:rPr lang="en-GB" sz="800" dirty="0" err="1">
+                <a:solidFill>
+                  <a:srgbClr val="000000"/>
+                </a:solidFill>
+                <a:effectLst/>
+                <a:latin typeface="Menlo" panose="020B0609030804020204" pitchFamily="49" charset="0"/>
+              </a:rPr>
+              <a:t>github</a:t>
+            </a:r>
+            <a:r>
+              <a:rPr lang="en-GB" sz="800" dirty="0">
+                <a:solidFill>
+                  <a:srgbClr val="000000"/>
+                </a:solidFill>
+                <a:effectLst/>
+                <a:latin typeface="Menlo" panose="020B0609030804020204" pitchFamily="49" charset="0"/>
+              </a:rPr>
+              <a:t>/</a:t>
+            </a:r>
+            <a:r>
+              <a:rPr lang="en-GB" sz="800" dirty="0" err="1">
+                <a:solidFill>
+                  <a:srgbClr val="000000"/>
+                </a:solidFill>
+                <a:effectLst/>
+                <a:latin typeface="Menlo" panose="020B0609030804020204" pitchFamily="49" charset="0"/>
+              </a:rPr>
+              <a:t>haml</a:t>
+            </a:r>
+            <a:r>
+              <a:rPr lang="en-GB" sz="800" dirty="0">
+                <a:solidFill>
+                  <a:srgbClr val="000000"/>
+                </a:solidFill>
+                <a:effectLst/>
+                <a:latin typeface="Menlo" panose="020B0609030804020204" pitchFamily="49" charset="0"/>
+              </a:rPr>
+              <a:t>/haml__version_0_4_1.xsd</a:t>
+            </a:r>
+            <a:br>
+              <a:rPr lang="en-GB" sz="800" dirty="0">
+                <a:solidFill>
+                  <a:srgbClr val="000000"/>
+                </a:solidFill>
+                <a:effectLst/>
+                <a:latin typeface="Menlo" panose="020B0609030804020204" pitchFamily="49" charset="0"/>
+              </a:rPr>
+            </a:br>
+            <a:br>
+              <a:rPr lang="en-GB" sz="800" dirty="0">
+                <a:solidFill>
+                  <a:srgbClr val="000000"/>
+                </a:solidFill>
+                <a:effectLst/>
+                <a:latin typeface="Menlo" panose="020B0609030804020204" pitchFamily="49" charset="0"/>
+              </a:rPr>
+            </a:br>
+            <a:br>
+              <a:rPr lang="en-GB" sz="800" dirty="0">
+                <a:solidFill>
+                  <a:srgbClr val="000000"/>
+                </a:solidFill>
+                <a:effectLst/>
+                <a:latin typeface="Menlo" panose="020B0609030804020204" pitchFamily="49" charset="0"/>
+              </a:rPr>
+            </a:br>
+            <a:endParaRPr lang="en-GB" dirty="0">
+              <a:effectLst/>
+              <a:latin typeface="Helvetica Neue" panose="02000503000000020004" pitchFamily="2" charset="0"/>
+            </a:endParaRPr>
+          </a:p>
+          <a:p>
+            <a:r>
+              <a:rPr lang="en-GB" dirty="0">
+                <a:effectLst/>
+                <a:latin typeface="Helvetica Neue" panose="02000503000000020004" pitchFamily="2" charset="0"/>
+                <a:hlinkClick r:id="rId4"/>
+              </a:rPr>
+              <a:t>https://www.freeformatter.com/xsd-generator.html</a:t>
+            </a:r>
+            <a:endParaRPr lang="en-GB" dirty="0">
+              <a:effectLst/>
+              <a:latin typeface="Helvetica Neue" panose="02000503000000020004" pitchFamily="2" charset="0"/>
+            </a:endParaRPr>
+          </a:p>
+          <a:p>
+            <a:pPr lvl="1"/>
+            <a:r>
+              <a:rPr lang="en-GB" dirty="0">
+                <a:latin typeface="Helvetica Neue" panose="02000503000000020004" pitchFamily="2" charset="0"/>
+              </a:rPr>
+              <a:t>Generate a naïve </a:t>
+            </a:r>
+            <a:r>
+              <a:rPr lang="en-GB" dirty="0" err="1">
+                <a:latin typeface="Helvetica Neue" panose="02000503000000020004" pitchFamily="2" charset="0"/>
+              </a:rPr>
+              <a:t>xsd</a:t>
+            </a:r>
+            <a:r>
+              <a:rPr lang="en-GB" dirty="0">
+                <a:latin typeface="Helvetica Neue" panose="02000503000000020004" pitchFamily="2" charset="0"/>
+              </a:rPr>
+              <a:t> schema from an xml document</a:t>
+            </a:r>
+            <a:br>
+              <a:rPr lang="en-GB" dirty="0">
+                <a:latin typeface="Helvetica Neue" panose="02000503000000020004" pitchFamily="2" charset="0"/>
+              </a:rPr>
+            </a:br>
+            <a:br>
+              <a:rPr lang="en-GB" dirty="0">
+                <a:latin typeface="Helvetica Neue" panose="02000503000000020004" pitchFamily="2" charset="0"/>
+              </a:rPr>
+            </a:br>
+            <a:endParaRPr lang="en-GB" dirty="0">
+              <a:effectLst/>
+              <a:latin typeface="Helvetica Neue" panose="02000503000000020004" pitchFamily="2" charset="0"/>
+            </a:endParaRPr>
+          </a:p>
+          <a:p>
+            <a:r>
+              <a:rPr lang="en-GB" dirty="0">
+                <a:effectLst/>
+                <a:latin typeface="Helvetica Neue" panose="02000503000000020004" pitchFamily="2" charset="0"/>
+                <a:hlinkClick r:id="rId5"/>
+              </a:rPr>
+              <a:t>https://www.liquid-technologies.com/online-xsd-validator</a:t>
+            </a:r>
+            <a:endParaRPr lang="en-GB" dirty="0">
+              <a:effectLst/>
+              <a:latin typeface="Helvetica Neue" panose="02000503000000020004" pitchFamily="2" charset="0"/>
+            </a:endParaRPr>
+          </a:p>
+          <a:p>
+            <a:pPr lvl="1"/>
+            <a:r>
+              <a:rPr lang="en-GB" dirty="0">
+                <a:latin typeface="Helvetica Neue" panose="02000503000000020004" pitchFamily="2" charset="0"/>
+              </a:rPr>
+              <a:t>Check if a sample xml is valid against an </a:t>
+            </a:r>
+            <a:r>
+              <a:rPr lang="en-GB" dirty="0" err="1">
+                <a:latin typeface="Helvetica Neue" panose="02000503000000020004" pitchFamily="2" charset="0"/>
+              </a:rPr>
+              <a:t>xsd</a:t>
+            </a:r>
+            <a:endParaRPr lang="en-GB" dirty="0">
+              <a:effectLst/>
+              <a:latin typeface="Helvetica Neue" panose="02000503000000020004" pitchFamily="2" charset="0"/>
+            </a:endParaRPr>
+          </a:p>
+          <a:p>
+            <a:endParaRPr lang="en-NL" dirty="0"/>
+          </a:p>
+        </p:txBody>
+      </p:sp>
+    </p:spTree>
+    <p:extLst>
+      <p:ext uri="{BB962C8B-B14F-4D97-AF65-F5344CB8AC3E}">
+        <p14:creationId xmlns:p14="http://schemas.microsoft.com/office/powerpoint/2010/main" val="974590270"/>
+      </p:ext>
+    </p:extLst>
+  </p:cSld>
+  <p:clrMapOvr>
+    <a:masterClrMapping/>
+  </p:clrMapOvr>
+</p:sld>
+</file>
+
+<file path=ppt/slides/slide11.xml><?xml version="1.0" encoding="utf-8"?>
+<p:sld xmlns:a="http://schemas.openxmlformats.org/drawingml/2006/main" xmlns:r="http://schemas.openxmlformats.org/officeDocument/2006/relationships" xmlns:p="http://schemas.openxmlformats.org/presentationml/2006/main">
+  <p:cSld>
+    <p:spTree>
+      <p:nvGrpSpPr>
         <p:cNvPr id="1" name="Shape 86"/>
         <p:cNvGrpSpPr/>
         <p:nvPr/>
@@ -6392,7 +6736,691 @@
 </p:sld>
 </file>
 
+<file path=ppt/slides/slide12.xml><?xml version="1.0" encoding="utf-8"?>
+<p:sld xmlns:a="http://schemas.openxmlformats.org/drawingml/2006/main" xmlns:r="http://schemas.openxmlformats.org/officeDocument/2006/relationships" xmlns:p="http://schemas.openxmlformats.org/presentationml/2006/main">
+  <p:cSld>
+    <p:spTree>
+      <p:nvGrpSpPr>
+        <p:cNvPr id="1" name=""/>
+        <p:cNvGrpSpPr/>
+        <p:nvPr/>
+      </p:nvGrpSpPr>
+      <p:grpSpPr>
+        <a:xfrm>
+          <a:off x="0" y="0"/>
+          <a:ext cx="0" cy="0"/>
+          <a:chOff x="0" y="0"/>
+          <a:chExt cx="0" cy="0"/>
+        </a:xfrm>
+      </p:grpSpPr>
+      <p:sp>
+        <p:nvSpPr>
+          <p:cNvPr id="2" name="Title 1">
+            <a:extLst>
+              <a:ext uri="{FF2B5EF4-FFF2-40B4-BE49-F238E27FC236}">
+                <a16:creationId xmlns:a16="http://schemas.microsoft.com/office/drawing/2014/main" id="{A1A13F88-A85B-B474-B154-3C981FA7D51A}"/>
+              </a:ext>
+            </a:extLst>
+          </p:cNvPr>
+          <p:cNvSpPr>
+            <a:spLocks noGrp="1"/>
+          </p:cNvSpPr>
+          <p:nvPr>
+            <p:ph type="title"/>
+          </p:nvPr>
+        </p:nvSpPr>
+        <p:spPr>
+          <a:xfrm>
+            <a:off x="194585" y="0"/>
+            <a:ext cx="8520600" cy="572700"/>
+          </a:xfrm>
+        </p:spPr>
+        <p:txBody>
+          <a:bodyPr>
+            <a:normAutofit fontScale="90000"/>
+          </a:bodyPr>
+          <a:lstStyle/>
+          <a:p>
+            <a:r>
+              <a:rPr lang="en-NL" dirty="0"/>
+              <a:t>Meeting minutes/notes</a:t>
+            </a:r>
+          </a:p>
+        </p:txBody>
+      </p:sp>
+      <p:sp>
+        <p:nvSpPr>
+          <p:cNvPr id="3" name="Text Placeholder 2">
+            <a:extLst>
+              <a:ext uri="{FF2B5EF4-FFF2-40B4-BE49-F238E27FC236}">
+                <a16:creationId xmlns:a16="http://schemas.microsoft.com/office/drawing/2014/main" id="{510CD711-0CC0-D5DA-06C7-CF1B0AC8A75D}"/>
+              </a:ext>
+            </a:extLst>
+          </p:cNvPr>
+          <p:cNvSpPr>
+            <a:spLocks noGrp="1"/>
+          </p:cNvSpPr>
+          <p:nvPr>
+            <p:ph type="body" idx="1"/>
+          </p:nvPr>
+        </p:nvSpPr>
+        <p:spPr>
+          <a:xfrm>
+            <a:off x="148646" y="454288"/>
+            <a:ext cx="8950309" cy="4689212"/>
+          </a:xfrm>
+        </p:spPr>
+        <p:txBody>
+          <a:bodyPr>
+            <a:noAutofit/>
+          </a:bodyPr>
+          <a:lstStyle/>
+          <a:p>
+            <a:pPr marL="114300" indent="0">
+              <a:buNone/>
+            </a:pPr>
+            <a:r>
+              <a:rPr lang="en-GB" sz="500" dirty="0"/>
+              <a:t>Order of operations:</a:t>
+            </a:r>
+          </a:p>
+          <a:p>
+            <a:pPr marL="114300" indent="0">
+              <a:buNone/>
+            </a:pPr>
+            <a:r>
+              <a:rPr lang="en-GB" sz="500" dirty="0"/>
+              <a:t>	Vet with Users and manufacturers</a:t>
+            </a:r>
+          </a:p>
+          <a:p>
+            <a:pPr marL="114300" indent="0">
+              <a:buNone/>
+            </a:pPr>
+            <a:r>
+              <a:rPr lang="en-GB" sz="500" dirty="0"/>
+              <a:t>	1.0 spec comes after that.</a:t>
+            </a:r>
+          </a:p>
+          <a:p>
+            <a:pPr marL="114300" indent="0">
+              <a:buNone/>
+            </a:pPr>
+            <a:endParaRPr lang="en-GB" sz="500" dirty="0"/>
+          </a:p>
+          <a:p>
+            <a:pPr marL="114300" indent="0">
+              <a:buNone/>
+            </a:pPr>
+            <a:r>
+              <a:rPr lang="en-GB" sz="500" dirty="0" err="1"/>
+              <a:t>PLString</a:t>
+            </a:r>
+            <a:r>
+              <a:rPr lang="en-GB" sz="500" dirty="0"/>
+              <a:t> -</a:t>
+            </a:r>
+          </a:p>
+          <a:p>
+            <a:pPr marL="114300" indent="0">
+              <a:buNone/>
+            </a:pPr>
+            <a:r>
+              <a:rPr lang="en-GB" sz="500" dirty="0"/>
+              <a:t>	define anchor residues in the Peptide String? Regular expression for peptides</a:t>
+            </a:r>
+          </a:p>
+          <a:p>
+            <a:pPr marL="114300" indent="0">
+              <a:buNone/>
+            </a:pPr>
+            <a:r>
+              <a:rPr lang="en-GB" sz="500" dirty="0"/>
+              <a:t>	Serological specificity  within a </a:t>
+            </a:r>
+            <a:r>
+              <a:rPr lang="en-GB" sz="500" dirty="0" err="1"/>
+              <a:t>plstring</a:t>
+            </a:r>
+            <a:endParaRPr lang="en-GB" sz="500" dirty="0"/>
+          </a:p>
+          <a:p>
+            <a:pPr marL="114300" indent="0">
+              <a:buNone/>
+            </a:pPr>
+            <a:r>
+              <a:rPr lang="en-GB" sz="500" dirty="0"/>
+              <a:t>	What if we don’t know the peptide? Modifications and such?</a:t>
+            </a:r>
+          </a:p>
+          <a:p>
+            <a:pPr marL="114300" indent="0">
+              <a:buNone/>
+            </a:pPr>
+            <a:r>
+              <a:rPr lang="en-GB" sz="500" dirty="0"/>
+              <a:t>		Extensions - “reserved characters” for future things</a:t>
+            </a:r>
+          </a:p>
+          <a:p>
+            <a:pPr marL="114300" indent="0">
+              <a:buNone/>
+            </a:pPr>
+            <a:r>
+              <a:rPr lang="en-GB" sz="500" dirty="0"/>
+              <a:t>		For now: Focus on the easy cases. Beads and things.</a:t>
+            </a:r>
+          </a:p>
+          <a:p>
+            <a:pPr marL="114300" indent="0">
+              <a:buNone/>
+            </a:pPr>
+            <a:r>
+              <a:rPr lang="en-GB" sz="500" dirty="0"/>
+              <a:t>	Modification to proposed nomenclature for peptides</a:t>
+            </a:r>
+          </a:p>
+          <a:p>
+            <a:pPr marL="114300" indent="0">
+              <a:buNone/>
+            </a:pPr>
+            <a:r>
+              <a:rPr lang="en-GB" sz="500" dirty="0"/>
+              <a:t>		DQB1*05:01~{PEPTIDE}~DQA1*01:01</a:t>
+            </a:r>
+          </a:p>
+          <a:p>
+            <a:pPr marL="114300" indent="0">
+              <a:buNone/>
+            </a:pPr>
+            <a:r>
+              <a:rPr lang="en-GB" sz="500" dirty="0"/>
+              <a:t>		DQB1*05:01~DQA1*01:01</a:t>
+            </a:r>
+          </a:p>
+          <a:p>
+            <a:pPr marL="114300" indent="0">
+              <a:buNone/>
+            </a:pPr>
+            <a:r>
+              <a:rPr lang="en-GB" sz="500" dirty="0"/>
+              <a:t>		A*01:01~{PEP}</a:t>
+            </a:r>
+          </a:p>
+          <a:p>
+            <a:pPr marL="114300" indent="0">
+              <a:buNone/>
+            </a:pPr>
+            <a:r>
+              <a:rPr lang="en-GB" sz="500" dirty="0"/>
+              <a:t>	Define example namespaces for epitopes/antigens/ambiguities</a:t>
+            </a:r>
+          </a:p>
+          <a:p>
+            <a:pPr marL="114300" indent="0">
+              <a:buNone/>
+            </a:pPr>
+            <a:r>
+              <a:rPr lang="en-GB" sz="500" dirty="0"/>
+              <a:t>		DPB1 “</a:t>
+            </a:r>
+            <a:r>
+              <a:rPr lang="en-GB" sz="500" dirty="0" err="1"/>
+              <a:t>unnacceptable</a:t>
+            </a:r>
+            <a:r>
+              <a:rPr lang="en-GB" sz="500" dirty="0"/>
+              <a:t> epitopes” , </a:t>
+            </a:r>
+            <a:r>
+              <a:rPr lang="en-GB" sz="500" dirty="0" err="1"/>
+              <a:t>Eplets</a:t>
+            </a:r>
+            <a:r>
+              <a:rPr lang="en-GB" sz="500" dirty="0"/>
+              <a:t>, </a:t>
+            </a:r>
+            <a:r>
+              <a:rPr lang="en-GB" sz="500" dirty="0" err="1"/>
+              <a:t>Cregs</a:t>
+            </a:r>
+            <a:r>
+              <a:rPr lang="en-GB" sz="500" dirty="0"/>
+              <a:t>, PIRCHES, alleles, serology, DPB1, MAC Codes</a:t>
+            </a:r>
+          </a:p>
+          <a:p>
+            <a:pPr marL="114300" indent="0">
+              <a:buNone/>
+            </a:pPr>
+            <a:r>
+              <a:rPr lang="en-GB" sz="500" dirty="0"/>
+              <a:t>		Show how to show which system is used (website or DOI)	</a:t>
+            </a:r>
+          </a:p>
+          <a:p>
+            <a:pPr marL="114300" indent="0">
+              <a:buNone/>
+            </a:pPr>
+            <a:r>
+              <a:rPr lang="en-GB" sz="500" dirty="0"/>
+              <a:t>		“Serotype list string”,  “</a:t>
+            </a:r>
+            <a:r>
+              <a:rPr lang="en-GB" sz="500" dirty="0" err="1"/>
+              <a:t>Eplet</a:t>
+            </a:r>
+            <a:r>
+              <a:rPr lang="en-GB" sz="500" dirty="0"/>
+              <a:t> String”</a:t>
+            </a:r>
+          </a:p>
+          <a:p>
+            <a:pPr marL="114300" indent="0">
+              <a:buNone/>
+            </a:pPr>
+            <a:endParaRPr lang="en-GB" sz="500" dirty="0"/>
+          </a:p>
+          <a:p>
+            <a:pPr marL="114300" indent="0">
+              <a:buNone/>
+            </a:pPr>
+            <a:r>
+              <a:rPr lang="en-GB" sz="500" dirty="0"/>
+              <a:t>Need to add a “Conclusion” which is a different idea than assay level interpretation</a:t>
+            </a:r>
+          </a:p>
+          <a:p>
+            <a:pPr marL="114300" indent="0">
+              <a:buNone/>
+            </a:pPr>
+            <a:r>
+              <a:rPr lang="en-GB" sz="500" dirty="0"/>
+              <a:t>	the targeted </a:t>
+            </a:r>
+            <a:r>
+              <a:rPr lang="en-GB" sz="500" dirty="0" err="1"/>
+              <a:t>eplets</a:t>
+            </a:r>
+            <a:r>
+              <a:rPr lang="en-GB" sz="500" dirty="0"/>
+              <a:t> go into here</a:t>
+            </a:r>
+          </a:p>
+          <a:p>
+            <a:pPr marL="114300" indent="0">
+              <a:buNone/>
+            </a:pPr>
+            <a:r>
+              <a:rPr lang="en-GB" sz="500" dirty="0"/>
+              <a:t>	Define </a:t>
+            </a:r>
+            <a:r>
+              <a:rPr lang="en-GB" sz="500" dirty="0" err="1"/>
+              <a:t>eplet</a:t>
+            </a:r>
+            <a:r>
+              <a:rPr lang="en-GB" sz="500" dirty="0"/>
+              <a:t> nomenclature.</a:t>
+            </a:r>
+          </a:p>
+          <a:p>
+            <a:pPr marL="114300" indent="0">
+              <a:buNone/>
+            </a:pPr>
+            <a:endParaRPr lang="en-GB" sz="500" dirty="0"/>
+          </a:p>
+          <a:p>
+            <a:pPr marL="114300" indent="0">
+              <a:buNone/>
+            </a:pPr>
+            <a:r>
+              <a:rPr lang="en-GB" sz="500" dirty="0"/>
+              <a:t>What is the use/purpose of this </a:t>
+            </a:r>
+            <a:r>
+              <a:rPr lang="en-GB" sz="500" dirty="0" err="1"/>
+              <a:t>haml</a:t>
+            </a:r>
+            <a:r>
+              <a:rPr lang="en-GB" sz="500" dirty="0"/>
+              <a:t> document? SOT….SCT?  Platelets?</a:t>
+            </a:r>
+          </a:p>
+          <a:p>
+            <a:pPr marL="114300" indent="0">
+              <a:buNone/>
+            </a:pPr>
+            <a:r>
+              <a:rPr lang="en-GB" sz="500" dirty="0"/>
+              <a:t>	Different interpretations for different contexts? Is this in the context of a patient/donor pair?</a:t>
+            </a:r>
+          </a:p>
+          <a:p>
+            <a:pPr marL="114300" indent="0">
+              <a:buNone/>
+            </a:pPr>
+            <a:r>
+              <a:rPr lang="en-GB" sz="500" dirty="0"/>
+              <a:t>	Allow generic reporting, and in interpretation 	</a:t>
+            </a:r>
+          </a:p>
+          <a:p>
+            <a:pPr marL="114300" indent="0">
+              <a:buNone/>
+            </a:pPr>
+            <a:r>
+              <a:rPr lang="en-GB" sz="500" dirty="0"/>
+              <a:t>	Specify what the report is intended for. Is this meant for SOT or is it meant for “Research” or SCT etc.</a:t>
+            </a:r>
+          </a:p>
+          <a:p>
+            <a:pPr marL="114300" indent="0">
+              <a:buNone/>
+            </a:pPr>
+            <a:r>
+              <a:rPr lang="en-GB" sz="500" dirty="0"/>
+              <a:t>	</a:t>
+            </a:r>
+          </a:p>
+          <a:p>
+            <a:pPr marL="114300" indent="0">
+              <a:buNone/>
+            </a:pPr>
+            <a:r>
+              <a:rPr lang="en-GB" sz="500" dirty="0"/>
+              <a:t>“Interpretation” should be flexible and handle MULTIPLE interpretation blocks:	</a:t>
+            </a:r>
+          </a:p>
+          <a:p>
+            <a:pPr marL="114300" indent="0">
+              <a:buNone/>
+            </a:pPr>
+            <a:r>
+              <a:rPr lang="en-GB" sz="500" dirty="0"/>
+              <a:t>	“Assay interpretation” - </a:t>
+            </a:r>
+          </a:p>
+          <a:p>
+            <a:pPr marL="114300" indent="0">
+              <a:buNone/>
+            </a:pPr>
+            <a:r>
+              <a:rPr lang="en-GB" sz="500" dirty="0"/>
+              <a:t>	“Clinical Interpretation”</a:t>
+            </a:r>
+          </a:p>
+          <a:p>
+            <a:pPr marL="114300" indent="0">
+              <a:buNone/>
+            </a:pPr>
+            <a:r>
+              <a:rPr lang="en-GB" sz="500" dirty="0"/>
+              <a:t>		Could include a field of use in here</a:t>
+            </a:r>
+          </a:p>
+          <a:p>
+            <a:pPr marL="114300" indent="0">
+              <a:buNone/>
+            </a:pPr>
+            <a:r>
+              <a:rPr lang="en-GB" sz="500" dirty="0"/>
+              <a:t>		In the context of transfusion we have these </a:t>
+            </a:r>
+            <a:r>
+              <a:rPr lang="en-GB" sz="500" dirty="0" err="1"/>
+              <a:t>unnacceptables</a:t>
+            </a:r>
+            <a:r>
+              <a:rPr lang="en-GB" sz="500" dirty="0"/>
+              <a:t>…</a:t>
+            </a:r>
+          </a:p>
+          <a:p>
+            <a:pPr marL="114300" indent="0">
+              <a:buNone/>
+            </a:pPr>
+            <a:endParaRPr lang="en-GB" sz="500" dirty="0"/>
+          </a:p>
+          <a:p>
+            <a:pPr marL="114300" indent="0">
+              <a:buNone/>
+            </a:pPr>
+            <a:r>
+              <a:rPr lang="en-GB" sz="500" dirty="0"/>
+              <a:t>Serum ID for positive and negative controls - these are in the csv export I think but no place in HAML</a:t>
+            </a:r>
+          </a:p>
+          <a:p>
+            <a:pPr marL="114300" indent="0">
+              <a:buNone/>
+            </a:pPr>
+            <a:endParaRPr lang="en-GB" sz="500" dirty="0"/>
+          </a:p>
+          <a:p>
+            <a:pPr marL="114300" indent="0">
+              <a:buNone/>
+            </a:pPr>
+            <a:r>
+              <a:rPr lang="en-GB" sz="500" dirty="0"/>
+              <a:t>Next Steps</a:t>
+            </a:r>
+          </a:p>
+          <a:p>
+            <a:pPr marL="114300" indent="0">
+              <a:buNone/>
+            </a:pPr>
+            <a:r>
+              <a:rPr lang="en-GB" sz="500" dirty="0"/>
+              <a:t>	Martin - Collaborations &amp; Datasets? set up a message creation and such with some collabs he has in mind</a:t>
+            </a:r>
+          </a:p>
+          <a:p>
+            <a:pPr marL="114300" indent="0">
+              <a:buNone/>
+            </a:pPr>
+            <a:r>
+              <a:rPr lang="en-GB" sz="500" dirty="0"/>
+              <a:t>	Loren and Nick csv of antibody exports from one lambda</a:t>
+            </a:r>
+          </a:p>
+          <a:p>
+            <a:pPr marL="114300" indent="0">
+              <a:buNone/>
+            </a:pPr>
+            <a:r>
+              <a:rPr lang="en-GB" sz="500" dirty="0"/>
+              <a:t>	Eventually re-convert IHIW stuff</a:t>
+            </a:r>
+          </a:p>
+          <a:p>
+            <a:pPr marL="114300" indent="0">
+              <a:buNone/>
+            </a:pPr>
+            <a:endParaRPr lang="en-GB" sz="500" dirty="0"/>
+          </a:p>
+          <a:p>
+            <a:pPr marL="114300" indent="0">
+              <a:buNone/>
+            </a:pPr>
+            <a:r>
+              <a:rPr lang="en-GB" sz="500" dirty="0"/>
+              <a:t>1-2 meetings in 2025 before </a:t>
+            </a:r>
+            <a:r>
+              <a:rPr lang="en-GB" sz="500" dirty="0" err="1"/>
+              <a:t>prague</a:t>
+            </a:r>
+            <a:endParaRPr lang="en-GB" sz="500" dirty="0"/>
+          </a:p>
+          <a:p>
+            <a:pPr marL="114300" indent="0">
+              <a:buNone/>
+            </a:pPr>
+            <a:r>
+              <a:rPr lang="en-GB" sz="500" dirty="0"/>
+              <a:t>Next meeting right before </a:t>
+            </a:r>
+            <a:r>
+              <a:rPr lang="en-GB" sz="500" dirty="0" err="1"/>
+              <a:t>xmas</a:t>
+            </a:r>
+            <a:r>
+              <a:rPr lang="en-GB" sz="500" dirty="0"/>
+              <a:t>.</a:t>
+            </a:r>
+          </a:p>
+          <a:p>
+            <a:pPr marL="114300" indent="0">
+              <a:buNone/>
+            </a:pPr>
+            <a:r>
+              <a:rPr lang="en-GB" sz="500" dirty="0"/>
+              <a:t>	Dec 9th or 16th same time? </a:t>
+            </a:r>
+          </a:p>
+          <a:p>
+            <a:pPr marL="114300" indent="0">
+              <a:buNone/>
+            </a:pPr>
+            <a:r>
+              <a:rPr lang="en-GB" sz="500" dirty="0"/>
+              <a:t>	Doodle poll is out https://</a:t>
+            </a:r>
+            <a:r>
+              <a:rPr lang="en-GB" sz="500" dirty="0" err="1"/>
+              <a:t>doodle.com</a:t>
+            </a:r>
+            <a:r>
+              <a:rPr lang="en-GB" sz="500" dirty="0"/>
+              <a:t>/meeting/organize/id/</a:t>
+            </a:r>
+            <a:r>
+              <a:rPr lang="en-GB" sz="500" dirty="0" err="1"/>
+              <a:t>eEGDQXmb</a:t>
+            </a:r>
+            <a:endParaRPr lang="en-GB" sz="500" dirty="0"/>
+          </a:p>
+          <a:p>
+            <a:pPr marL="114300" indent="0">
+              <a:buNone/>
+            </a:pPr>
+            <a:endParaRPr lang="en-NL" sz="500" dirty="0"/>
+          </a:p>
+        </p:txBody>
+      </p:sp>
+    </p:spTree>
+    <p:extLst>
+      <p:ext uri="{BB962C8B-B14F-4D97-AF65-F5344CB8AC3E}">
+        <p14:creationId xmlns:p14="http://schemas.microsoft.com/office/powerpoint/2010/main" val="1916555232"/>
+      </p:ext>
+    </p:extLst>
+  </p:cSld>
+  <p:clrMapOvr>
+    <a:masterClrMapping/>
+  </p:clrMapOvr>
+</p:sld>
+</file>
+
 <file path=ppt/slides/slide2.xml><?xml version="1.0" encoding="utf-8"?>
+<p:sld xmlns:a="http://schemas.openxmlformats.org/drawingml/2006/main" xmlns:r="http://schemas.openxmlformats.org/officeDocument/2006/relationships" xmlns:p="http://schemas.openxmlformats.org/presentationml/2006/main">
+  <p:cSld>
+    <p:spTree>
+      <p:nvGrpSpPr>
+        <p:cNvPr id="1" name=""/>
+        <p:cNvGrpSpPr/>
+        <p:nvPr/>
+      </p:nvGrpSpPr>
+      <p:grpSpPr>
+        <a:xfrm>
+          <a:off x="0" y="0"/>
+          <a:ext cx="0" cy="0"/>
+          <a:chOff x="0" y="0"/>
+          <a:chExt cx="0" cy="0"/>
+        </a:xfrm>
+      </p:grpSpPr>
+      <p:sp>
+        <p:nvSpPr>
+          <p:cNvPr id="2" name="Title 1">
+            <a:extLst>
+              <a:ext uri="{FF2B5EF4-FFF2-40B4-BE49-F238E27FC236}">
+                <a16:creationId xmlns:a16="http://schemas.microsoft.com/office/drawing/2014/main" id="{479829A3-E275-1290-D808-391136C01CA0}"/>
+              </a:ext>
+            </a:extLst>
+          </p:cNvPr>
+          <p:cNvSpPr>
+            <a:spLocks noGrp="1"/>
+          </p:cNvSpPr>
+          <p:nvPr>
+            <p:ph type="title"/>
+          </p:nvPr>
+        </p:nvSpPr>
+        <p:spPr/>
+        <p:txBody>
+          <a:bodyPr>
+            <a:normAutofit fontScale="90000"/>
+          </a:bodyPr>
+          <a:lstStyle/>
+          <a:p>
+            <a:r>
+              <a:rPr lang="en-NL" dirty="0"/>
+              <a:t>HAML Working Group</a:t>
+            </a:r>
+          </a:p>
+        </p:txBody>
+      </p:sp>
+      <p:sp>
+        <p:nvSpPr>
+          <p:cNvPr id="3" name="Text Placeholder 2">
+            <a:extLst>
+              <a:ext uri="{FF2B5EF4-FFF2-40B4-BE49-F238E27FC236}">
+                <a16:creationId xmlns:a16="http://schemas.microsoft.com/office/drawing/2014/main" id="{6B9B942B-C948-4223-C6B5-50690C495606}"/>
+              </a:ext>
+            </a:extLst>
+          </p:cNvPr>
+          <p:cNvSpPr>
+            <a:spLocks noGrp="1"/>
+          </p:cNvSpPr>
+          <p:nvPr>
+            <p:ph type="body" idx="1"/>
+          </p:nvPr>
+        </p:nvSpPr>
+        <p:spPr/>
+        <p:txBody>
+          <a:bodyPr/>
+          <a:lstStyle/>
+          <a:p>
+            <a:r>
+              <a:rPr lang="en-NL" dirty="0"/>
+              <a:t>What have we done so far?</a:t>
+            </a:r>
+            <a:br>
+              <a:rPr lang="en-NL" dirty="0"/>
+            </a:br>
+            <a:endParaRPr lang="en-NL" dirty="0"/>
+          </a:p>
+          <a:p>
+            <a:r>
+              <a:rPr lang="en-NL" dirty="0"/>
+              <a:t>What needs to be done moving forward?</a:t>
+            </a:r>
+          </a:p>
+        </p:txBody>
+      </p:sp>
+    </p:spTree>
+    <p:extLst>
+      <p:ext uri="{BB962C8B-B14F-4D97-AF65-F5344CB8AC3E}">
+        <p14:creationId xmlns:p14="http://schemas.microsoft.com/office/powerpoint/2010/main" val="1022362959"/>
+      </p:ext>
+    </p:extLst>
+  </p:cSld>
+  <p:clrMapOvr>
+    <a:masterClrMapping/>
+  </p:clrMapOvr>
+</p:sld>
+</file>
+
+<file path=ppt/slides/slide3.xml><?xml version="1.0" encoding="utf-8"?>
 <p:sld xmlns:a="http://schemas.openxmlformats.org/drawingml/2006/main" xmlns:r="http://schemas.openxmlformats.org/officeDocument/2006/relationships" xmlns:p="http://schemas.openxmlformats.org/presentationml/2006/main">
   <p:cSld>
     <p:spTree>
@@ -6581,7 +7609,7 @@
 </p:sld>
 </file>
 
-<file path=ppt/slides/slide3.xml><?xml version="1.0" encoding="utf-8"?>
+<file path=ppt/slides/slide4.xml><?xml version="1.0" encoding="utf-8"?>
 <p:sld xmlns:a="http://schemas.openxmlformats.org/drawingml/2006/main" xmlns:r="http://schemas.openxmlformats.org/officeDocument/2006/relationships" xmlns:p="http://schemas.openxmlformats.org/presentationml/2006/main">
   <p:cSld>
     <p:spTree>
@@ -6911,7 +7939,7 @@
 </p:sld>
 </file>
 
-<file path=ppt/slides/slide4.xml><?xml version="1.0" encoding="utf-8"?>
+<file path=ppt/slides/slide5.xml><?xml version="1.0" encoding="utf-8"?>
 <p:sld xmlns:a="http://schemas.openxmlformats.org/drawingml/2006/main" xmlns:r="http://schemas.openxmlformats.org/officeDocument/2006/relationships" xmlns:p="http://schemas.openxmlformats.org/presentationml/2006/main">
   <p:cSld>
     <p:spTree>
@@ -7194,7 +8222,7 @@
 </p:sld>
 </file>
 
-<file path=ppt/slides/slide5.xml><?xml version="1.0" encoding="utf-8"?>
+<file path=ppt/slides/slide6.xml><?xml version="1.0" encoding="utf-8"?>
 <p:sld xmlns:a="http://schemas.openxmlformats.org/drawingml/2006/main" xmlns:r="http://schemas.openxmlformats.org/officeDocument/2006/relationships" xmlns:p="http://schemas.openxmlformats.org/presentationml/2006/main">
   <p:cSld>
     <p:spTree>
@@ -7416,7 +8444,7 @@
 </p:sld>
 </file>
 
-<file path=ppt/slides/slide6.xml><?xml version="1.0" encoding="utf-8"?>
+<file path=ppt/slides/slide7.xml><?xml version="1.0" encoding="utf-8"?>
 <p:sld xmlns:a="http://schemas.openxmlformats.org/drawingml/2006/main" xmlns:r="http://schemas.openxmlformats.org/officeDocument/2006/relationships" xmlns:p="http://schemas.openxmlformats.org/presentationml/2006/main">
   <p:cSld>
     <p:spTree>
@@ -8026,7 +9054,7 @@
 </p:sld>
 </file>
 
-<file path=ppt/slides/slide7.xml><?xml version="1.0" encoding="utf-8"?>
+<file path=ppt/slides/slide8.xml><?xml version="1.0" encoding="utf-8"?>
 <p:sld xmlns:a="http://schemas.openxmlformats.org/drawingml/2006/main" xmlns:r="http://schemas.openxmlformats.org/officeDocument/2006/relationships" xmlns:p="http://schemas.openxmlformats.org/presentationml/2006/main">
   <p:cSld>
     <p:spTree>
@@ -8285,7 +9313,7 @@
 </p:sld>
 </file>
 
-<file path=ppt/slides/slide8.xml><?xml version="1.0" encoding="utf-8"?>
+<file path=ppt/slides/slide9.xml><?xml version="1.0" encoding="utf-8"?>
 <p:sld xmlns:a="http://schemas.openxmlformats.org/drawingml/2006/main" xmlns:r="http://schemas.openxmlformats.org/officeDocument/2006/relationships" xmlns:p="http://schemas.openxmlformats.org/presentationml/2006/main">
   <p:cSld>
     <p:spTree>
@@ -8314,7 +9342,7 @@
         </p:nvSpPr>
         <p:spPr>
           <a:xfrm>
-            <a:off x="311700" y="445025"/>
+            <a:off x="311700" y="146639"/>
             <a:ext cx="8520600" cy="572700"/>
           </a:xfrm>
           <a:prstGeom prst="rect">
@@ -8356,7 +9384,7 @@
         </p:nvSpPr>
         <p:spPr>
           <a:xfrm>
-            <a:off x="227479" y="941923"/>
+            <a:off x="227479" y="586991"/>
             <a:ext cx="8520600" cy="3416400"/>
           </a:xfrm>
           <a:prstGeom prst="rect">
@@ -8410,6 +9438,17 @@
               <a:rPr lang="en" sz="1000" dirty="0"/>
               <a:t>More precision on data types &amp; Dates</a:t>
             </a:r>
+          </a:p>
+          <a:p>
+            <a:pPr lvl="1"/>
+            <a:r>
+              <a:rPr lang="en" sz="1000" dirty="0"/>
+              <a:t>Documentation &amp; Comments within the </a:t>
+            </a:r>
+            <a:r>
+              <a:rPr lang="en" sz="1000" dirty="0" err="1"/>
+              <a:t>xsd</a:t>
+            </a:r>
             <a:br>
               <a:rPr lang="en" sz="1000" dirty="0"/>
             </a:br>
@@ -8420,6 +9459,27 @@
               <a:rPr lang="en" sz="1000" dirty="0"/>
               <a:t>Define scope (add cell assays?)</a:t>
             </a:r>
+          </a:p>
+          <a:p>
+            <a:endParaRPr lang="en" sz="1000" dirty="0"/>
+          </a:p>
+          <a:p>
+            <a:r>
+              <a:rPr lang="en" sz="1000" dirty="0" err="1"/>
+              <a:t>PLString</a:t>
+            </a:r>
+            <a:r>
+              <a:rPr lang="en" sz="1000" dirty="0"/>
+              <a:t> – examples and detailed description (check </a:t>
+            </a:r>
+            <a:r>
+              <a:rPr lang="en" sz="1000" dirty="0" err="1"/>
+              <a:t>GLString</a:t>
+            </a:r>
+            <a:r>
+              <a:rPr lang="en" sz="1000" dirty="0"/>
+              <a:t> for inspiration)</a:t>
+            </a:r>
             <a:endParaRPr sz="1000" dirty="0"/>
           </a:p>
           <a:p>
@@ -8430,16 +9490,9 @@
             <a:pPr marL="311150" indent="-171450"/>
             <a:r>
               <a:rPr lang="en" sz="1000" dirty="0"/>
-              <a:t>    Make it a healthcare guideline through FHIR</a:t>
+              <a:t>    Write a implementation guide / healthcare guideline through FHIR</a:t>
             </a:r>
             <a:endParaRPr sz="1000" dirty="0"/>
-          </a:p>
-          <a:p>
-            <a:pPr lvl="1"/>
-            <a:r>
-              <a:rPr lang="en" sz="1000" dirty="0"/>
-              <a:t>Write a implementation guide.</a:t>
-            </a:r>
           </a:p>
           <a:p>
             <a:pPr lvl="1"/>
@@ -8521,355 +9574,13 @@
           <a:p>
             <a:r>
               <a:rPr lang="en-GB" sz="1000" dirty="0"/>
-              <a:t>Long term: Hackathon with antibody vendors to tell them what to do and how to do it</a:t>
+              <a:t>Long term: Hackathon with antibody analysis vendors to tell them what to do and how to do it</a:t>
             </a:r>
             <a:endParaRPr sz="1000" dirty="0"/>
           </a:p>
         </p:txBody>
       </p:sp>
     </p:spTree>
-  </p:cSld>
-  <p:clrMapOvr>
-    <a:masterClrMapping/>
-  </p:clrMapOvr>
-</p:sld>
-</file>
-
-<file path=ppt/slides/slide9.xml><?xml version="1.0" encoding="utf-8"?>
-<p:sld xmlns:a="http://schemas.openxmlformats.org/drawingml/2006/main" xmlns:r="http://schemas.openxmlformats.org/officeDocument/2006/relationships" xmlns:p="http://schemas.openxmlformats.org/presentationml/2006/main">
-  <p:cSld>
-    <p:spTree>
-      <p:nvGrpSpPr>
-        <p:cNvPr id="1" name=""/>
-        <p:cNvGrpSpPr/>
-        <p:nvPr/>
-      </p:nvGrpSpPr>
-      <p:grpSpPr>
-        <a:xfrm>
-          <a:off x="0" y="0"/>
-          <a:ext cx="0" cy="0"/>
-          <a:chOff x="0" y="0"/>
-          <a:chExt cx="0" cy="0"/>
-        </a:xfrm>
-      </p:grpSpPr>
-      <p:sp>
-        <p:nvSpPr>
-          <p:cNvPr id="2" name="Title 1">
-            <a:extLst>
-              <a:ext uri="{FF2B5EF4-FFF2-40B4-BE49-F238E27FC236}">
-                <a16:creationId xmlns:a16="http://schemas.microsoft.com/office/drawing/2014/main" id="{0A8CF40D-5DEC-82FB-80E2-93FE6A785734}"/>
-              </a:ext>
-            </a:extLst>
-          </p:cNvPr>
-          <p:cNvSpPr>
-            <a:spLocks noGrp="1"/>
-          </p:cNvSpPr>
-          <p:nvPr>
-            <p:ph type="title"/>
-          </p:nvPr>
-        </p:nvSpPr>
-        <p:spPr/>
-        <p:txBody>
-          <a:bodyPr>
-            <a:normAutofit fontScale="90000"/>
-          </a:bodyPr>
-          <a:lstStyle/>
-          <a:p>
-            <a:r>
-              <a:rPr lang="en-NL" dirty="0"/>
-              <a:t>Tools &amp; Links</a:t>
-            </a:r>
-          </a:p>
-        </p:txBody>
-      </p:sp>
-      <p:sp>
-        <p:nvSpPr>
-          <p:cNvPr id="3" name="Text Placeholder 2">
-            <a:extLst>
-              <a:ext uri="{FF2B5EF4-FFF2-40B4-BE49-F238E27FC236}">
-                <a16:creationId xmlns:a16="http://schemas.microsoft.com/office/drawing/2014/main" id="{5F87125B-831A-433A-F4B2-3D1BBBB95F01}"/>
-              </a:ext>
-            </a:extLst>
-          </p:cNvPr>
-          <p:cNvSpPr>
-            <a:spLocks noGrp="1"/>
-          </p:cNvSpPr>
-          <p:nvPr>
-            <p:ph type="body" idx="1"/>
-          </p:nvPr>
-        </p:nvSpPr>
-        <p:spPr/>
-        <p:txBody>
-          <a:bodyPr>
-            <a:normAutofit lnSpcReduction="10000"/>
-          </a:bodyPr>
-          <a:lstStyle/>
-          <a:p>
-            <a:r>
-              <a:rPr lang="en-GB" dirty="0">
-                <a:hlinkClick r:id="rId2"/>
-              </a:rPr>
-              <a:t>https://github.com/bmatern/haml</a:t>
-            </a:r>
-            <a:endParaRPr lang="en-GB" dirty="0">
-              <a:effectLst/>
-              <a:latin typeface="Helvetica Neue" panose="02000503000000020004" pitchFamily="2" charset="0"/>
-              <a:hlinkClick r:id="rId3"/>
-            </a:endParaRPr>
-          </a:p>
-          <a:p>
-            <a:endParaRPr lang="en-GB" dirty="0">
-              <a:latin typeface="Helvetica Neue" panose="02000503000000020004" pitchFamily="2" charset="0"/>
-              <a:hlinkClick r:id="rId3"/>
-            </a:endParaRPr>
-          </a:p>
-          <a:p>
-            <a:r>
-              <a:rPr lang="en-GB" dirty="0">
-                <a:effectLst/>
-                <a:latin typeface="Helvetica Neue" panose="02000503000000020004" pitchFamily="2" charset="0"/>
-                <a:hlinkClick r:id="rId3"/>
-              </a:rPr>
-              <a:t>https://sourceforge.net/projects/xsdvi/</a:t>
-            </a:r>
-            <a:endParaRPr lang="en-GB" dirty="0">
-              <a:effectLst/>
-              <a:latin typeface="Helvetica Neue" panose="02000503000000020004" pitchFamily="2" charset="0"/>
-            </a:endParaRPr>
-          </a:p>
-          <a:p>
-            <a:pPr lvl="1"/>
-            <a:r>
-              <a:rPr lang="en-GB" dirty="0">
-                <a:effectLst/>
-                <a:latin typeface="Helvetica Neue" panose="02000503000000020004" pitchFamily="2" charset="0"/>
-              </a:rPr>
-              <a:t>Java-based </a:t>
-            </a:r>
-            <a:r>
-              <a:rPr lang="en-GB" dirty="0">
-                <a:latin typeface="Helvetica Neue" panose="02000503000000020004" pitchFamily="2" charset="0"/>
-              </a:rPr>
-              <a:t>schema diagram generator</a:t>
-            </a:r>
-          </a:p>
-          <a:p>
-            <a:pPr lvl="1"/>
-            <a:r>
-              <a:rPr lang="en-GB" sz="800" dirty="0">
-                <a:solidFill>
-                  <a:srgbClr val="000000"/>
-                </a:solidFill>
-                <a:effectLst/>
-                <a:latin typeface="Menlo" panose="020B0609030804020204" pitchFamily="49" charset="0"/>
-              </a:rPr>
-              <a:t>java -jar </a:t>
-            </a:r>
-            <a:r>
-              <a:rPr lang="en-GB" sz="800" dirty="0" err="1">
-                <a:solidFill>
-                  <a:srgbClr val="000000"/>
-                </a:solidFill>
-                <a:effectLst/>
-                <a:latin typeface="Menlo" panose="020B0609030804020204" pitchFamily="49" charset="0"/>
-              </a:rPr>
-              <a:t>dist</a:t>
-            </a:r>
-            <a:r>
-              <a:rPr lang="en-GB" sz="800" dirty="0">
-                <a:solidFill>
-                  <a:srgbClr val="000000"/>
-                </a:solidFill>
-                <a:effectLst/>
-                <a:latin typeface="Menlo" panose="020B0609030804020204" pitchFamily="49" charset="0"/>
-              </a:rPr>
-              <a:t>/lib/</a:t>
-            </a:r>
-            <a:r>
-              <a:rPr lang="en-GB" sz="800" dirty="0" err="1">
-                <a:solidFill>
-                  <a:srgbClr val="000000"/>
-                </a:solidFill>
-                <a:effectLst/>
-                <a:latin typeface="Menlo" panose="020B0609030804020204" pitchFamily="49" charset="0"/>
-              </a:rPr>
-              <a:t>xsdvi.jar</a:t>
-            </a:r>
-            <a:r>
-              <a:rPr lang="en-GB" sz="800" dirty="0">
-                <a:solidFill>
-                  <a:srgbClr val="000000"/>
-                </a:solidFill>
-                <a:effectLst/>
-                <a:latin typeface="Menlo" panose="020B0609030804020204" pitchFamily="49" charset="0"/>
-              </a:rPr>
-              <a:t> /Users/ben/</a:t>
-            </a:r>
-            <a:r>
-              <a:rPr lang="en-GB" sz="800" dirty="0" err="1">
-                <a:solidFill>
-                  <a:srgbClr val="000000"/>
-                </a:solidFill>
-                <a:effectLst/>
-                <a:latin typeface="Menlo" panose="020B0609030804020204" pitchFamily="49" charset="0"/>
-              </a:rPr>
-              <a:t>github</a:t>
-            </a:r>
-            <a:r>
-              <a:rPr lang="en-GB" sz="800" dirty="0">
-                <a:solidFill>
-                  <a:srgbClr val="000000"/>
-                </a:solidFill>
-                <a:effectLst/>
-                <a:latin typeface="Menlo" panose="020B0609030804020204" pitchFamily="49" charset="0"/>
-              </a:rPr>
-              <a:t>/</a:t>
-            </a:r>
-            <a:r>
-              <a:rPr lang="en-GB" sz="800" dirty="0" err="1">
-                <a:solidFill>
-                  <a:srgbClr val="000000"/>
-                </a:solidFill>
-                <a:effectLst/>
-                <a:latin typeface="Menlo" panose="020B0609030804020204" pitchFamily="49" charset="0"/>
-              </a:rPr>
-              <a:t>haml</a:t>
-            </a:r>
-            <a:r>
-              <a:rPr lang="en-GB" sz="800" dirty="0">
-                <a:solidFill>
-                  <a:srgbClr val="000000"/>
-                </a:solidFill>
-                <a:effectLst/>
-                <a:latin typeface="Menlo" panose="020B0609030804020204" pitchFamily="49" charset="0"/>
-              </a:rPr>
-              <a:t>/haml__version_0_4_1.xsd</a:t>
-            </a:r>
-            <a:br>
-              <a:rPr lang="en-GB" sz="800" dirty="0">
-                <a:solidFill>
-                  <a:srgbClr val="000000"/>
-                </a:solidFill>
-                <a:effectLst/>
-                <a:latin typeface="Menlo" panose="020B0609030804020204" pitchFamily="49" charset="0"/>
-              </a:rPr>
-            </a:br>
-            <a:br>
-              <a:rPr lang="en-GB" sz="800" dirty="0">
-                <a:solidFill>
-                  <a:srgbClr val="000000"/>
-                </a:solidFill>
-                <a:effectLst/>
-                <a:latin typeface="Menlo" panose="020B0609030804020204" pitchFamily="49" charset="0"/>
-              </a:rPr>
-            </a:br>
-            <a:br>
-              <a:rPr lang="en-GB" sz="800" dirty="0">
-                <a:solidFill>
-                  <a:srgbClr val="000000"/>
-                </a:solidFill>
-                <a:effectLst/>
-                <a:latin typeface="Menlo" panose="020B0609030804020204" pitchFamily="49" charset="0"/>
-              </a:rPr>
-            </a:br>
-            <a:endParaRPr lang="en-GB" dirty="0">
-              <a:effectLst/>
-              <a:latin typeface="Helvetica Neue" panose="02000503000000020004" pitchFamily="2" charset="0"/>
-            </a:endParaRPr>
-          </a:p>
-          <a:p>
-            <a:r>
-              <a:rPr lang="en-GB" dirty="0">
-                <a:effectLst/>
-                <a:latin typeface="Helvetica Neue" panose="02000503000000020004" pitchFamily="2" charset="0"/>
-                <a:hlinkClick r:id="rId4"/>
-              </a:rPr>
-              <a:t>https://www.freeformatter.com/xsd-generator.html</a:t>
-            </a:r>
-            <a:endParaRPr lang="en-GB" dirty="0">
-              <a:effectLst/>
-              <a:latin typeface="Helvetica Neue" panose="02000503000000020004" pitchFamily="2" charset="0"/>
-            </a:endParaRPr>
-          </a:p>
-          <a:p>
-            <a:pPr lvl="1"/>
-            <a:r>
-              <a:rPr lang="en-GB" dirty="0">
-                <a:latin typeface="Helvetica Neue" panose="02000503000000020004" pitchFamily="2" charset="0"/>
-              </a:rPr>
-              <a:t>Generate a naïve </a:t>
-            </a:r>
-            <a:r>
-              <a:rPr lang="en-GB" dirty="0" err="1">
-                <a:latin typeface="Helvetica Neue" panose="02000503000000020004" pitchFamily="2" charset="0"/>
-              </a:rPr>
-              <a:t>xsd</a:t>
-            </a:r>
-            <a:r>
-              <a:rPr lang="en-GB" dirty="0">
-                <a:latin typeface="Helvetica Neue" panose="02000503000000020004" pitchFamily="2" charset="0"/>
-              </a:rPr>
-              <a:t> schema from an xml document</a:t>
-            </a:r>
-            <a:br>
-              <a:rPr lang="en-GB" dirty="0">
-                <a:latin typeface="Helvetica Neue" panose="02000503000000020004" pitchFamily="2" charset="0"/>
-              </a:rPr>
-            </a:br>
-            <a:br>
-              <a:rPr lang="en-GB" dirty="0">
-                <a:latin typeface="Helvetica Neue" panose="02000503000000020004" pitchFamily="2" charset="0"/>
-              </a:rPr>
-            </a:br>
-            <a:endParaRPr lang="en-GB" dirty="0">
-              <a:effectLst/>
-              <a:latin typeface="Helvetica Neue" panose="02000503000000020004" pitchFamily="2" charset="0"/>
-            </a:endParaRPr>
-          </a:p>
-          <a:p>
-            <a:r>
-              <a:rPr lang="en-GB" dirty="0">
-                <a:effectLst/>
-                <a:latin typeface="Helvetica Neue" panose="02000503000000020004" pitchFamily="2" charset="0"/>
-                <a:hlinkClick r:id="rId5"/>
-              </a:rPr>
-              <a:t>https://www.liquid-technologies.com/online-xsd-validator</a:t>
-            </a:r>
-            <a:endParaRPr lang="en-GB" dirty="0">
-              <a:effectLst/>
-              <a:latin typeface="Helvetica Neue" panose="02000503000000020004" pitchFamily="2" charset="0"/>
-            </a:endParaRPr>
-          </a:p>
-          <a:p>
-            <a:pPr lvl="1"/>
-            <a:r>
-              <a:rPr lang="en-GB" dirty="0">
-                <a:latin typeface="Helvetica Neue" panose="02000503000000020004" pitchFamily="2" charset="0"/>
-              </a:rPr>
-              <a:t>Check if a sample xml is valid against an </a:t>
-            </a:r>
-            <a:r>
-              <a:rPr lang="en-GB" dirty="0" err="1">
-                <a:latin typeface="Helvetica Neue" panose="02000503000000020004" pitchFamily="2" charset="0"/>
-              </a:rPr>
-              <a:t>xsd</a:t>
-            </a:r>
-            <a:endParaRPr lang="en-GB" dirty="0">
-              <a:effectLst/>
-              <a:latin typeface="Helvetica Neue" panose="02000503000000020004" pitchFamily="2" charset="0"/>
-            </a:endParaRPr>
-          </a:p>
-          <a:p>
-            <a:endParaRPr lang="en-NL" dirty="0"/>
-          </a:p>
-        </p:txBody>
-      </p:sp>
-    </p:spTree>
-    <p:extLst>
-      <p:ext uri="{BB962C8B-B14F-4D97-AF65-F5344CB8AC3E}">
-        <p14:creationId xmlns:p14="http://schemas.microsoft.com/office/powerpoint/2010/main" val="974590270"/>
-      </p:ext>
-    </p:extLst>
   </p:cSld>
   <p:clrMapOvr>
     <a:masterClrMapping/>

</xml_diff>